<commit_message>
Add open-weight dimension: license flags, catch-up chart, appendix slide
- open_weights column in models.csv (yes/no/unverified, conservative)
- chart4_open_weight_catchup: open vs closed capability envelopes over time
- Appendix slide 4 with speaker notes; README/SOURCES updated

Co-Authored-By: Claude Fable 5 <noreply@anthropic.com>
Claude-Session: https://claude.ai/code/session_01KUHbvNyqdjNDAspy7vctkr
</commit_message>
<xml_diff>
--- a/analysis/super-moores-law/slides/super-moores-law.pptx
+++ b/analysis/super-moores-law/slides/super-moores-law.pptx
@@ -8,9 +8,10 @@
     <p:sldId id="256" r:id="rId2"/>
     <p:sldId id="257" r:id="rId3"/>
     <p:sldId id="258" r:id="rId4"/>
+    <p:sldId id="259" r:id="rId5"/>
   </p:sldIdLst>
   <p:notesMasterIdLst>
-    <p:notesMasterId r:id="rId5"/>
+    <p:notesMasterId r:id="rId6"/>
   </p:notesMasterIdLst>
   <p:sldSz cx="12192000" cy="6858000"/>
   <p:notesSz cx="6858000" cy="12192000"/>
@@ -704,6 +705,94 @@
             <a:fld id="{F7021451-1387-4CA6-816F-3879F97B5CBC}" type="slidenum">
               <a:rPr lang="en-US"/>
               <a:t>3</a:t>
+            </a:fld>
+            <a:endParaRPr lang="en-US"/>
+          </a:p>
+        </p:txBody>
+      </p:sp>
+    </p:spTree>
+    <p:extLst>
+      <p:ext uri="{BB962C8B-B14F-4D97-AF65-F5344CB8AC3E}">
+        <p14:creationId xmlns:p14="http://schemas.microsoft.com/office/powerpoint/2010/main" val="1024086991"/>
+      </p:ext>
+    </p:extLst>
+  </p:cSld>
+  <p:clrMapOvr>
+    <a:masterClrMapping/>
+  </p:clrMapOvr>
+</p:notes>
+</file>
+
+<file path=ppt/notesSlides/notesSlide4.xml><?xml version="1.0" encoding="utf-8"?>
+<p:notes xmlns:a="http://schemas.openxmlformats.org/drawingml/2006/main" xmlns:r="http://schemas.openxmlformats.org/officeDocument/2006/relationships" xmlns:p="http://schemas.openxmlformats.org/presentationml/2006/main">
+  <p:cSld>
+    <p:spTree>
+      <p:nvGrpSpPr>
+        <p:cNvPr id="1" name=""/>
+        <p:cNvGrpSpPr/>
+        <p:nvPr/>
+      </p:nvGrpSpPr>
+      <p:grpSpPr>
+        <a:xfrm>
+          <a:off x="0" y="0"/>
+          <a:ext cx="0" cy="0"/>
+          <a:chOff x="0" y="0"/>
+          <a:chExt cx="0" cy="0"/>
+        </a:xfrm>
+      </p:grpSpPr>
+      <p:sp>
+        <p:nvSpPr>
+          <p:cNvPr id="2" name="Slide Image Placeholder 1"/>
+          <p:cNvSpPr>
+            <a:spLocks noGrp="1" noRot="1" noChangeAspect="1"/>
+          </p:cNvSpPr>
+          <p:nvPr>
+            <p:ph type="sldImg"/>
+          </p:nvPr>
+        </p:nvSpPr>
+        <p:spPr/>
+      </p:sp>
+      <p:sp>
+        <p:nvSpPr>
+          <p:cNvPr id="3" name="Notes Placeholder 2"/>
+          <p:cNvSpPr>
+            <a:spLocks noGrp="1"/>
+          </p:cNvSpPr>
+          <p:nvPr>
+            <p:ph type="body" idx="1"/>
+          </p:nvPr>
+        </p:nvSpPr>
+        <p:spPr/>
+        <p:txBody>
+          <a:bodyPr/>
+          <a:lstStyle/>
+          <a:p>
+            <a:r>
+              <a:rPr lang="en-US" dirty="0"/>
+              <a:t>Optional appendix if open source comes up. Both lines show the best capability score achieved to date, split by license: blue is closed/proprietary, orange is models whose weights you can download. Three beats. First, the gap: in 2023 Llama 2 was about a year behind GPT-4-class capability; DeepSeek R1 matched o1-class reasoning roughly one month after o1's API launch; in 2026 Kimi K3 sits a few points and a few months behind the closed frontier. Second, price: the open ecosystem sets the floor. DeepSeek V2 started the Chinese price war in May 2024; R1 undercut o1 by 27x; V4-Pro is an MIT-licensed, million-token-context frontier model at 87 cents per million output tokens — one to three percent of closed flagship prices. Third, nuance: open-weight does not mean free to serve — someone still runs the GPUs — and the very top of the leaderboard remains closed (Opus 5, GPT-5.6 Sol, Fable 5). Also note the counter-trend: the strongest open models, Kimi K3 and Qwen's flagships, now price UP toward closed-tier rates. For VetIntel: open-weight availability is the credible threat that keeps every closed vendor's pricing honest, and it is what makes self-hosted or private deployments of near-frontier capability plausible for data-sensitive workloads like ours.</a:t>
+            </a:r>
+            <a:endParaRPr lang="en-US" dirty="0"/>
+          </a:p>
+        </p:txBody>
+      </p:sp>
+      <p:sp>
+        <p:nvSpPr>
+          <p:cNvPr id="4" name="Slide Number Placeholder 3"/>
+          <p:cNvSpPr>
+            <a:spLocks noGrp="1"/>
+          </p:cNvSpPr>
+          <p:nvPr>
+            <p:ph type="sldNum" sz="quarter" idx="10"/>
+          </p:nvPr>
+        </p:nvSpPr>
+        <p:spPr/>
+        <p:txBody>
+          <a:bodyPr/>
+          <a:lstStyle/>
+          <a:p>
+            <a:fld id="{F7021451-1387-4CA6-816F-3879F97B5CBC}" type="slidenum">
+              <a:rPr lang="en-US"/>
+              <a:t>4</a:t>
             </a:fld>
             <a:endParaRPr lang="en-US"/>
           </a:p>
@@ -2652,6 +2741,547 @@
 </p:sld>
 </file>
 
+<file path=ppt/slides/slide4.xml><?xml version="1.0" encoding="utf-8"?>
+<p:sld xmlns:a="http://schemas.openxmlformats.org/drawingml/2006/main" xmlns:r="http://schemas.openxmlformats.org/officeDocument/2006/relationships" xmlns:p="http://schemas.openxmlformats.org/presentationml/2006/main">
+  <p:cSld name="Slide 4">
+    <p:bg>
+      <p:bgPr>
+        <a:solidFill>
+          <a:srgbClr val="FFFFFF"/>
+        </a:solidFill>
+      </p:bgPr>
+    </p:bg>
+    <p:spTree>
+      <p:nvGrpSpPr>
+        <p:cNvPr id="1" name=""/>
+        <p:cNvGrpSpPr/>
+        <p:nvPr/>
+      </p:nvGrpSpPr>
+      <p:grpSpPr>
+        <a:xfrm>
+          <a:off x="0" y="0"/>
+          <a:ext cx="0" cy="0"/>
+          <a:chOff x="0" y="0"/>
+          <a:chExt cx="0" cy="0"/>
+        </a:xfrm>
+      </p:grpSpPr>
+      <p:sp>
+        <p:nvSpPr>
+          <p:cNvPr id="2" name="Text 0"/>
+          <p:cNvSpPr/>
+          <p:nvPr/>
+        </p:nvSpPr>
+        <p:spPr>
+          <a:xfrm>
+            <a:off x="457200" y="256032"/>
+            <a:ext cx="11247120" cy="566928"/>
+          </a:xfrm>
+          <a:prstGeom prst="rect">
+            <a:avLst/>
+          </a:prstGeom>
+          <a:noFill/>
+          <a:ln/>
+        </p:spPr>
+        <p:txBody>
+          <a:bodyPr wrap="square" lIns="0" tIns="0" rIns="0" bIns="0" rtlCol="0" anchor="ctr"/>
+          <a:lstStyle/>
+          <a:p>
+            <a:pPr indent="0" marL="0">
+              <a:buNone/>
+            </a:pPr>
+            <a:r>
+              <a:rPr lang="en-US" sz="3200" b="1" dirty="0">
+                <a:solidFill>
+                  <a:srgbClr val="0B0B0B"/>
+                </a:solidFill>
+                <a:latin typeface="Calibri" pitchFamily="34" charset="0"/>
+                <a:ea typeface="Calibri" pitchFamily="34" charset="-122"/>
+                <a:cs typeface="Calibri" pitchFamily="34" charset="-120"/>
+              </a:rPr>
+              <a:t>Appendix: The Open-Weight Catch-Up</a:t>
+            </a:r>
+            <a:endParaRPr lang="en-US" sz="3200" dirty="0"/>
+          </a:p>
+        </p:txBody>
+      </p:sp>
+      <p:sp>
+        <p:nvSpPr>
+          <p:cNvPr id="3" name="Text 1"/>
+          <p:cNvSpPr/>
+          <p:nvPr/>
+        </p:nvSpPr>
+        <p:spPr>
+          <a:xfrm>
+            <a:off x="457200" y="841248"/>
+            <a:ext cx="11247120" cy="329184"/>
+          </a:xfrm>
+          <a:prstGeom prst="rect">
+            <a:avLst/>
+          </a:prstGeom>
+          <a:noFill/>
+          <a:ln/>
+        </p:spPr>
+        <p:txBody>
+          <a:bodyPr wrap="square" lIns="0" tIns="0" rIns="0" bIns="0" rtlCol="0" anchor="ctr"/>
+          <a:lstStyle/>
+          <a:p>
+            <a:pPr indent="0" marL="0">
+              <a:buNone/>
+            </a:pPr>
+            <a:r>
+              <a:rPr lang="en-US" sz="1400" i="1" dirty="0">
+                <a:solidFill>
+                  <a:srgbClr val="52514E"/>
+                </a:solidFill>
+                <a:latin typeface="Calibri" pitchFamily="34" charset="0"/>
+                <a:ea typeface="Calibri" pitchFamily="34" charset="-122"/>
+                <a:cs typeface="Calibri" pitchFamily="34" charset="-120"/>
+              </a:rPr>
+              <a:t>Open-source models are the engine of the price collapse — and now trail the closed frontier by months, not years.</a:t>
+            </a:r>
+            <a:endParaRPr lang="en-US" sz="1400" dirty="0"/>
+          </a:p>
+        </p:txBody>
+      </p:sp>
+      <p:pic>
+        <p:nvPicPr>
+          <p:cNvPr id="4" name="Image 0" descr="charts/chart4_open_weight_catchup.png">    </p:cNvPr>
+          <p:cNvPicPr>
+            <a:picLocks noChangeAspect="1"/>
+          </p:cNvPicPr>
+          <p:nvPr/>
+        </p:nvPicPr>
+        <p:blipFill>
+          <a:blip r:embed="rId1"/>
+          <a:stretch>
+            <a:fillRect/>
+          </a:stretch>
+        </p:blipFill>
+        <p:spPr>
+          <a:xfrm>
+            <a:off x="384048" y="1298448"/>
+            <a:ext cx="8549640" cy="4206240"/>
+          </a:xfrm>
+          <a:prstGeom prst="rect">
+            <a:avLst/>
+          </a:prstGeom>
+        </p:spPr>
+      </p:pic>
+      <p:sp>
+        <p:nvSpPr>
+          <p:cNvPr id="5" name="Shape 2"/>
+          <p:cNvSpPr/>
+          <p:nvPr/>
+        </p:nvSpPr>
+        <p:spPr>
+          <a:xfrm>
+            <a:off x="9098280" y="1298448"/>
+            <a:ext cx="2651760" cy="1371600"/>
+          </a:xfrm>
+          <a:prstGeom prst="roundRect">
+            <a:avLst>
+              <a:gd name="adj" fmla="val 5333"/>
+            </a:avLst>
+          </a:prstGeom>
+          <a:solidFill>
+            <a:srgbClr val="FDEFE9"/>
+          </a:solidFill>
+          <a:ln/>
+        </p:spPr>
+      </p:sp>
+      <p:sp>
+        <p:nvSpPr>
+          <p:cNvPr id="6" name="Text 3"/>
+          <p:cNvSpPr/>
+          <p:nvPr/>
+        </p:nvSpPr>
+        <p:spPr>
+          <a:xfrm>
+            <a:off x="9281160" y="1408176"/>
+            <a:ext cx="2286000" cy="502920"/>
+          </a:xfrm>
+          <a:prstGeom prst="rect">
+            <a:avLst/>
+          </a:prstGeom>
+          <a:noFill/>
+          <a:ln/>
+        </p:spPr>
+        <p:txBody>
+          <a:bodyPr wrap="square" lIns="0" tIns="0" rIns="0" bIns="0" rtlCol="0" anchor="ctr"/>
+          <a:lstStyle/>
+          <a:p>
+            <a:pPr indent="0" marL="0">
+              <a:buNone/>
+            </a:pPr>
+            <a:r>
+              <a:rPr lang="en-US" sz="2700" b="1" dirty="0">
+                <a:solidFill>
+                  <a:srgbClr val="EB6834"/>
+                </a:solidFill>
+                <a:latin typeface="Calibri" pitchFamily="34" charset="0"/>
+                <a:ea typeface="Calibri" pitchFamily="34" charset="-122"/>
+                <a:cs typeface="Calibri" pitchFamily="34" charset="-120"/>
+              </a:rPr>
+              <a:t>~3–6 mo</a:t>
+            </a:r>
+            <a:endParaRPr lang="en-US" sz="2700" dirty="0"/>
+          </a:p>
+        </p:txBody>
+      </p:sp>
+      <p:sp>
+        <p:nvSpPr>
+          <p:cNvPr id="7" name="Text 4"/>
+          <p:cNvSpPr/>
+          <p:nvPr/>
+        </p:nvSpPr>
+        <p:spPr>
+          <a:xfrm>
+            <a:off x="9281160" y="1901952"/>
+            <a:ext cx="2331720" cy="658368"/>
+          </a:xfrm>
+          <a:prstGeom prst="rect">
+            <a:avLst/>
+          </a:prstGeom>
+          <a:noFill/>
+          <a:ln/>
+        </p:spPr>
+        <p:txBody>
+          <a:bodyPr wrap="square" lIns="0" tIns="0" rIns="0" bIns="0" rtlCol="0" anchor="ctr"/>
+          <a:lstStyle/>
+          <a:p>
+            <a:pPr indent="0" marL="0">
+              <a:lnSpc>
+                <a:spcPct val="105000"/>
+              </a:lnSpc>
+              <a:buNone/>
+            </a:pPr>
+            <a:r>
+              <a:rPr lang="en-US" sz="1050" dirty="0">
+                <a:solidFill>
+                  <a:srgbClr val="52514E"/>
+                </a:solidFill>
+                <a:latin typeface="Calibri" pitchFamily="34" charset="0"/>
+                <a:ea typeface="Calibri" pitchFamily="34" charset="-122"/>
+                <a:cs typeface="Calibri" pitchFamily="34" charset="-120"/>
+              </a:rPr>
+              <a:t>capability lag of the best open-weight model behind the closed frontier in 2026 — down from ~a year in 2023</a:t>
+            </a:r>
+            <a:endParaRPr lang="en-US" sz="1050" dirty="0"/>
+          </a:p>
+        </p:txBody>
+      </p:sp>
+      <p:sp>
+        <p:nvSpPr>
+          <p:cNvPr id="8" name="Shape 5"/>
+          <p:cNvSpPr/>
+          <p:nvPr/>
+        </p:nvSpPr>
+        <p:spPr>
+          <a:xfrm>
+            <a:off x="9098280" y="2807208"/>
+            <a:ext cx="2651760" cy="1371600"/>
+          </a:xfrm>
+          <a:prstGeom prst="roundRect">
+            <a:avLst>
+              <a:gd name="adj" fmla="val 5333"/>
+            </a:avLst>
+          </a:prstGeom>
+          <a:solidFill>
+            <a:srgbClr val="FDEFE9"/>
+          </a:solidFill>
+          <a:ln/>
+        </p:spPr>
+      </p:sp>
+      <p:sp>
+        <p:nvSpPr>
+          <p:cNvPr id="9" name="Text 6"/>
+          <p:cNvSpPr/>
+          <p:nvPr/>
+        </p:nvSpPr>
+        <p:spPr>
+          <a:xfrm>
+            <a:off x="9281160" y="2916936"/>
+            <a:ext cx="2286000" cy="502920"/>
+          </a:xfrm>
+          <a:prstGeom prst="rect">
+            <a:avLst/>
+          </a:prstGeom>
+          <a:noFill/>
+          <a:ln/>
+        </p:spPr>
+        <p:txBody>
+          <a:bodyPr wrap="square" lIns="0" tIns="0" rIns="0" bIns="0" rtlCol="0" anchor="ctr"/>
+          <a:lstStyle/>
+          <a:p>
+            <a:pPr indent="0" marL="0">
+              <a:buNone/>
+            </a:pPr>
+            <a:r>
+              <a:rPr lang="en-US" sz="2700" b="1" dirty="0">
+                <a:solidFill>
+                  <a:srgbClr val="EB6834"/>
+                </a:solidFill>
+                <a:latin typeface="Calibri" pitchFamily="34" charset="0"/>
+                <a:ea typeface="Calibri" pitchFamily="34" charset="-122"/>
+                <a:cs typeface="Calibri" pitchFamily="34" charset="-120"/>
+              </a:rPr>
+              <a:t>1/27th</a:t>
+            </a:r>
+            <a:endParaRPr lang="en-US" sz="2700" dirty="0"/>
+          </a:p>
+        </p:txBody>
+      </p:sp>
+      <p:sp>
+        <p:nvSpPr>
+          <p:cNvPr id="10" name="Text 7"/>
+          <p:cNvSpPr/>
+          <p:nvPr/>
+        </p:nvSpPr>
+        <p:spPr>
+          <a:xfrm>
+            <a:off x="9281160" y="3410712"/>
+            <a:ext cx="2331720" cy="658368"/>
+          </a:xfrm>
+          <a:prstGeom prst="rect">
+            <a:avLst/>
+          </a:prstGeom>
+          <a:noFill/>
+          <a:ln/>
+        </p:spPr>
+        <p:txBody>
+          <a:bodyPr wrap="square" lIns="0" tIns="0" rIns="0" bIns="0" rtlCol="0" anchor="ctr"/>
+          <a:lstStyle/>
+          <a:p>
+            <a:pPr indent="0" marL="0">
+              <a:lnSpc>
+                <a:spcPct val="105000"/>
+              </a:lnSpc>
+              <a:buNone/>
+            </a:pPr>
+            <a:r>
+              <a:rPr lang="en-US" sz="1050" dirty="0">
+                <a:solidFill>
+                  <a:srgbClr val="52514E"/>
+                </a:solidFill>
+                <a:latin typeface="Calibri" pitchFamily="34" charset="0"/>
+                <a:ea typeface="Calibri" pitchFamily="34" charset="-122"/>
+                <a:cs typeface="Calibri" pitchFamily="34" charset="-120"/>
+              </a:rPr>
+              <a:t>DeepSeek R1's output price vs OpenAI o1 at launch (Jan 2025: $2.19 vs $60 per 1M) — the 'DeepSeek shock'</a:t>
+            </a:r>
+            <a:endParaRPr lang="en-US" sz="1050" dirty="0"/>
+          </a:p>
+        </p:txBody>
+      </p:sp>
+      <p:sp>
+        <p:nvSpPr>
+          <p:cNvPr id="11" name="Shape 8"/>
+          <p:cNvSpPr/>
+          <p:nvPr/>
+        </p:nvSpPr>
+        <p:spPr>
+          <a:xfrm>
+            <a:off x="9098280" y="4315968"/>
+            <a:ext cx="2651760" cy="1371600"/>
+          </a:xfrm>
+          <a:prstGeom prst="roundRect">
+            <a:avLst>
+              <a:gd name="adj" fmla="val 5333"/>
+            </a:avLst>
+          </a:prstGeom>
+          <a:solidFill>
+            <a:srgbClr val="EAF2FC"/>
+          </a:solidFill>
+          <a:ln/>
+        </p:spPr>
+      </p:sp>
+      <p:sp>
+        <p:nvSpPr>
+          <p:cNvPr id="12" name="Text 9"/>
+          <p:cNvSpPr/>
+          <p:nvPr/>
+        </p:nvSpPr>
+        <p:spPr>
+          <a:xfrm>
+            <a:off x="9281160" y="4425696"/>
+            <a:ext cx="2286000" cy="502920"/>
+          </a:xfrm>
+          <a:prstGeom prst="rect">
+            <a:avLst/>
+          </a:prstGeom>
+          <a:noFill/>
+          <a:ln/>
+        </p:spPr>
+        <p:txBody>
+          <a:bodyPr wrap="square" lIns="0" tIns="0" rIns="0" bIns="0" rtlCol="0" anchor="ctr"/>
+          <a:lstStyle/>
+          <a:p>
+            <a:pPr indent="0" marL="0">
+              <a:buNone/>
+            </a:pPr>
+            <a:r>
+              <a:rPr lang="en-US" sz="2700" b="1" dirty="0">
+                <a:solidFill>
+                  <a:srgbClr val="2A78D6"/>
+                </a:solidFill>
+                <a:latin typeface="Calibri" pitchFamily="34" charset="0"/>
+                <a:ea typeface="Calibri" pitchFamily="34" charset="-122"/>
+                <a:cs typeface="Calibri" pitchFamily="34" charset="-120"/>
+              </a:rPr>
+              <a:t>$0.87</a:t>
+            </a:r>
+            <a:endParaRPr lang="en-US" sz="2700" dirty="0"/>
+          </a:p>
+        </p:txBody>
+      </p:sp>
+      <p:sp>
+        <p:nvSpPr>
+          <p:cNvPr id="13" name="Text 10"/>
+          <p:cNvSpPr/>
+          <p:nvPr/>
+        </p:nvSpPr>
+        <p:spPr>
+          <a:xfrm>
+            <a:off x="9281160" y="4919472"/>
+            <a:ext cx="2331720" cy="658368"/>
+          </a:xfrm>
+          <a:prstGeom prst="rect">
+            <a:avLst/>
+          </a:prstGeom>
+          <a:noFill/>
+          <a:ln/>
+        </p:spPr>
+        <p:txBody>
+          <a:bodyPr wrap="square" lIns="0" tIns="0" rIns="0" bIns="0" rtlCol="0" anchor="ctr"/>
+          <a:lstStyle/>
+          <a:p>
+            <a:pPr indent="0" marL="0">
+              <a:lnSpc>
+                <a:spcPct val="105000"/>
+              </a:lnSpc>
+              <a:buNone/>
+            </a:pPr>
+            <a:r>
+              <a:rPr lang="en-US" sz="1050" dirty="0">
+                <a:solidFill>
+                  <a:srgbClr val="52514E"/>
+                </a:solidFill>
+                <a:latin typeface="Calibri" pitchFamily="34" charset="0"/>
+                <a:ea typeface="Calibri" pitchFamily="34" charset="-122"/>
+                <a:cs typeface="Calibri" pitchFamily="34" charset="-120"/>
+              </a:rPr>
+              <a:t>output price of open-weight DeepSeek V4-Pro (MIT license, 1M context) vs $25–50 for closed flagships</a:t>
+            </a:r>
+            <a:endParaRPr lang="en-US" sz="1050" dirty="0"/>
+          </a:p>
+        </p:txBody>
+      </p:sp>
+      <p:sp>
+        <p:nvSpPr>
+          <p:cNvPr id="14" name="Text 11"/>
+          <p:cNvSpPr/>
+          <p:nvPr/>
+        </p:nvSpPr>
+        <p:spPr>
+          <a:xfrm>
+            <a:off x="457200" y="5614416"/>
+            <a:ext cx="11247120" cy="731520"/>
+          </a:xfrm>
+          <a:prstGeom prst="rect">
+            <a:avLst/>
+          </a:prstGeom>
+          <a:noFill/>
+          <a:ln/>
+        </p:spPr>
+        <p:txBody>
+          <a:bodyPr wrap="square" lIns="0" tIns="0" rIns="0" bIns="0" rtlCol="0" anchor="ctr"/>
+          <a:lstStyle/>
+          <a:p>
+            <a:pPr indent="0" marL="0">
+              <a:lnSpc>
+                <a:spcPct val="110000"/>
+              </a:lnSpc>
+              <a:buNone/>
+            </a:pPr>
+            <a:r>
+              <a:rPr lang="en-US" sz="1100" b="1" dirty="0">
+                <a:solidFill>
+                  <a:srgbClr val="0B0B0B"/>
+                </a:solidFill>
+                <a:latin typeface="Calibri" pitchFamily="34" charset="0"/>
+                <a:ea typeface="Calibri" pitchFamily="34" charset="-122"/>
+                <a:cs typeface="Calibri" pitchFamily="34" charset="-120"/>
+              </a:rPr>
+              <a:t>Open-weight examples in the dataset: </a:t>
+            </a:r>
+            <a:pPr indent="0" marL="0">
+              <a:lnSpc>
+                <a:spcPct val="110000"/>
+              </a:lnSpc>
+              <a:buNone/>
+            </a:pPr>
+            <a:r>
+              <a:rPr lang="en-US" sz="1100" dirty="0">
+                <a:solidFill>
+                  <a:srgbClr val="52514E"/>
+                </a:solidFill>
+                <a:latin typeface="Calibri" pitchFamily="34" charset="0"/>
+                <a:ea typeface="Calibri" pitchFamily="34" charset="-122"/>
+                <a:cs typeface="Calibri" pitchFamily="34" charset="-120"/>
+              </a:rPr>
+              <a:t>Meta Llama 2 / 3.1 405B / 4 · DeepSeek V2, V3, R1, V3.2, V4-Pro (MIT) · Mistral Mixtral &amp; Large 2/3 (Apache 2.0) · Qwen 3 (Apache 2.0) · Kimi K2 / K3 (modified MIT — K3 is the largest open-weight model ever at 2.8T params). Open-weight releases triggered the May-2024 China price war and keep resetting the industry price floor.</a:t>
+            </a:r>
+            <a:endParaRPr lang="en-US" sz="1100" dirty="0"/>
+          </a:p>
+        </p:txBody>
+      </p:sp>
+      <p:sp>
+        <p:nvSpPr>
+          <p:cNvPr id="15" name="Text 12"/>
+          <p:cNvSpPr/>
+          <p:nvPr/>
+        </p:nvSpPr>
+        <p:spPr>
+          <a:xfrm>
+            <a:off x="457200" y="6455664"/>
+            <a:ext cx="11247120" cy="274320"/>
+          </a:xfrm>
+          <a:prstGeom prst="rect">
+            <a:avLst/>
+          </a:prstGeom>
+          <a:noFill/>
+          <a:ln/>
+        </p:spPr>
+        <p:txBody>
+          <a:bodyPr wrap="square" lIns="0" tIns="0" rIns="0" bIns="0" rtlCol="0" anchor="ctr"/>
+          <a:lstStyle/>
+          <a:p>
+            <a:pPr indent="0" marL="0">
+              <a:buNone/>
+            </a:pPr>
+            <a:r>
+              <a:rPr lang="en-US" sz="850" dirty="0">
+                <a:solidFill>
+                  <a:srgbClr val="898781"/>
+                </a:solidFill>
+                <a:latin typeface="Calibri" pitchFamily="34" charset="0"/>
+                <a:ea typeface="Calibri" pitchFamily="34" charset="-122"/>
+                <a:cs typeface="Calibri" pitchFamily="34" charset="-120"/>
+              </a:rPr>
+              <a:t>License status per model in data/models.csv (open_weights column; 'unverified' flagged). Lag measured on the same capability composite as Slide 2. Sources: SOURCES.md.</a:t>
+            </a:r>
+            <a:endParaRPr lang="en-US" sz="850" dirty="0"/>
+          </a:p>
+        </p:txBody>
+      </p:sp>
+    </p:spTree>
+  </p:cSld>
+  <p:clrMapOvr>
+    <a:masterClrMapping/>
+  </p:clrMapOvr>
+</p:sld>
+</file>
+
 <file path=ppt/theme/theme1.xml><?xml version="1.0" encoding="utf-8"?>
 <a:theme xmlns:a="http://schemas.openxmlformats.org/drawingml/2006/main" name="Office Theme">
   <a:themeElements>

</xml_diff>